<commit_message>
Bring the deck in line with the verified CLI behaviour
Slide 6 runs the plain three-flag command (Step 1 uses no sandbox or config).
Slide 7 shows Step 4's actual command: view,grep,glob,edit,create and a blanket
shell deny; drops apply_patch (not a tool on 1.0.83) and the git-specific rules.
Slide 8 allows shell(az) exactly as the README does — the exact-with-space form
provably does not match — and its notes point at /sandbox, the only introspection
subcommand that exists.
</commit_message>
<xml_diff>
--- a/copilot-cli-real-infra-deck.pptx
+++ b/copilot-cli-real-infra-deck.pptx
@@ -1393,7 +1393,7 @@
           <a:p/>
           <a:p>
             <a:r>
-              <a:t>Then /sandbox policy. Do not read it aloud -- point at the denied .env, the writable path, and allowOutbound false.</a:t>
+              <a:t>Then /sandbox. Do not read it aloud -- point at the denied .env, the writable path, and allowOutbound false.</a:t>
             </a:r>
           </a:p>
         </p:txBody>
@@ -10106,7 +10106,7 @@
                 </a:solidFill>
                 <a:latin typeface="Courier New"/>
               </a:rPr>
-              <a:t>COPILOT_HOME="$RO" copilot --experimental --sandbox \</a:t>
+              <a:t>copilot \</a:t>
             </a:r>
           </a:p>
           <a:p>
@@ -10595,7 +10595,7 @@
                 </a:solidFill>
                 <a:latin typeface="Courier New"/>
               </a:rPr>
-              <a:t>COPILOT_HOME="$RW" copilot --experimental --sandbox \</a:t>
+              <a:t>COPILOT_HOME="$LAB_HOME" copilot --experimental --sandbox \</a:t>
             </a:r>
           </a:p>
           <a:p>
@@ -10611,7 +10611,7 @@
                 </a:solidFill>
                 <a:latin typeface="Courier New"/>
               </a:rPr>
-              <a:t>  --available-tools=...,bash,edit,create,apply_patch \</a:t>
+              <a:t>  --available-tools=view,grep,glob,edit,create \</a:t>
             </a:r>
           </a:p>
           <a:p>
@@ -10627,7 +10627,7 @@
                 </a:solidFill>
                 <a:latin typeface="Courier New"/>
               </a:rPr>
-              <a:t>  --allow-tool='read,shell(git status),shell(git diff)' \</a:t>
+              <a:t>  --deny-tool='shell,write(.env)'</a:t>
             </a:r>
           </a:p>
           <a:p>
@@ -10643,7 +10643,7 @@
                 </a:solidFill>
                 <a:latin typeface="Courier New"/>
               </a:rPr>
-              <a:t>  --deny-tool='shell(git push),shell(terraform),</a:t>
+              <a:t/>
             </a:r>
           </a:p>
           <a:p>
@@ -10659,7 +10659,7 @@
                 </a:solidFill>
                 <a:latin typeface="Courier New"/>
               </a:rPr>
-              <a:t>               shell(terraform:*),shell(gcloud),shell(gcloud:*)'</a:t>
+              <a:t/>
             </a:r>
           </a:p>
         </p:txBody>
@@ -11100,7 +11100,7 @@
                 </a:solidFill>
                 <a:latin typeface="Courier New"/>
               </a:rPr>
-              <a:t>  --allow-tool='read,shell(az --version)' \</a:t>
+              <a:t>  --allow-tool='shell(az)' \</a:t>
             </a:r>
           </a:p>
           <a:p>

</xml_diff>